<commit_message>
Stage 8 review fixes: E-024
</commit_message>
<xml_diff>
--- a/output/archive/Archive/Users/garethb_old_laptop/Commercial/Capacity_Reviews/CHAMBER_CAPACITY_2017_Rev02.pptx
+++ b/output/archive/Archive/Users/garethb_old_laptop/Commercial/Capacity_Reviews/CHAMBER_CAPACITY_2017_Rev02.pptx
@@ -6,12 +6,11 @@
   </p:sldMasterIdLst>
   <p:sldIdLst>
     <p:sldId id="256" r:id="rId7"/>
-    <p:sldId id="257" r:id="rId8"/>
+    <p:sldId id="257" r:id="rId9"/>
     <p:sldId id="258" r:id="rId10"/>
     <p:sldId id="259" r:id="rId11"/>
     <p:sldId id="260" r:id="rId12"/>
     <p:sldId id="261" r:id="rId13"/>
-    <p:sldId id="262" r:id="rId14"/>
   </p:sldIdLst>
   <p:sldSz cx="12191695" cy="6858000" type="screen4x3"/>
   <p:notesSz cx="6858000" cy="9144000"/>
@@ -508,7 +507,7 @@
           <a:lstStyle/>
           <a:p>
             <a:r>
-              <a:t>Keep this out of the client folders. For Alice and Leon to look at before Thursday.</a:t>
+              <a:t>Final review copy for 2017 planning. Kept on my laptop; use the live chamber and pull records when quoting.</a:t>
             </a:r>
           </a:p>
         </p:txBody>
@@ -578,7 +577,7 @@
           <a:lstStyle/>
           <a:p>
             <a:r>
-              <a:t>Loading status is from the chamber log as of last week. Not checked against the LIMS yet.</a:t>
+              <a:t>For Alice and Leon at the quote review. Keep client result reports out of this copy.</a:t>
             </a:r>
           </a:p>
         </p:txBody>
@@ -648,7 +647,7 @@
           <a:lstStyle/>
           <a:p>
             <a:r>
-              <a:t>Pull calendar is in the shared drive. This is my reading of it, so check against the original.</a:t>
+              <a:t>Read these together. A pull date alone is not a chamber vacancy date; remaining samples may still occupy the position.</a:t>
             </a:r>
           </a:p>
         </p:txBody>
@@ -718,7 +717,7 @@
           <a:lstStyle/>
           <a:p>
             <a:r>
-              <a:t>Saira has the current analytical slots. Confirm before we quote anything with a start in the new year.</a:t>
+              <a:t>Use the current pull calendar, not dates copied into an old commercial slide.</a:t>
             </a:r>
           </a:p>
         </p:txBody>
@@ -788,7 +787,77 @@
           <a:lstStyle/>
           <a:p>
             <a:r>
-              <a:t>Paper records before the electronic archive are patchy, so anything older than 2011 is from memory and should be marked that way.</a:t>
+              <a:t>No fixed loading interval is established here. Confirm with Alice if the requested timing depends on an exception to normal arrangements.</a:t>
+            </a:r>
+          </a:p>
+        </p:txBody>
+      </p:sp>
+      <p:sp>
+        <p:nvSpPr>
+          <p:cNvPr id="4" name="Slide Number Placeholder 3"/>
+          <p:cNvSpPr>
+            <a:spLocks noGrp="1"/>
+          </p:cNvSpPr>
+          <p:nvPr>
+            <p:ph type="sldNum" idx="5" sz="quarter"/>
+          </p:nvPr>
+        </p:nvSpPr>
+        <p:spPr/>
+      </p:sp>
+    </p:spTree>
+  </p:cSld>
+  <p:clrMapOvr>
+    <a:masterClrMapping/>
+  </p:clrMapOvr>
+</p:notes>
+</file>
+
+<file path=ppt/notesSlides/notesSlide6.xml><?xml version="1.0" encoding="utf-8"?>
+<p:notes xmlns:a="http://schemas.openxmlformats.org/drawingml/2006/main" xmlns:p="http://schemas.openxmlformats.org/presentationml/2006/main" xmlns:r="http://schemas.openxmlformats.org/officeDocument/2006/relationships">
+  <p:cSld>
+    <p:spTree>
+      <p:nvGrpSpPr>
+        <p:cNvPr id="1" name=""/>
+        <p:cNvGrpSpPr/>
+        <p:nvPr/>
+      </p:nvGrpSpPr>
+      <p:grpSpPr>
+        <a:xfrm>
+          <a:off x="0" y="0"/>
+          <a:ext cx="0" cy="0"/>
+          <a:chOff x="0" y="0"/>
+          <a:chExt cx="0" cy="0"/>
+        </a:xfrm>
+      </p:grpSpPr>
+      <p:sp>
+        <p:nvSpPr>
+          <p:cNvPr id="2" name="Slide Image Placeholder 1"/>
+          <p:cNvSpPr>
+            <a:spLocks noGrp="1"/>
+          </p:cNvSpPr>
+          <p:nvPr>
+            <p:ph type="sldImg" idx="2"/>
+          </p:nvPr>
+        </p:nvSpPr>
+        <p:spPr/>
+      </p:sp>
+      <p:sp>
+        <p:nvSpPr>
+          <p:cNvPr id="3" name="Notes Placeholder 2"/>
+          <p:cNvSpPr>
+            <a:spLocks noGrp="1"/>
+          </p:cNvSpPr>
+          <p:nvPr>
+            <p:ph type="body" idx="3" sz="quarter"/>
+          </p:nvPr>
+        </p:nvSpPr>
+        <p:spPr/>
+        <p:txBody>
+          <a:bodyPr/>
+          <a:lstStyle/>
+          <a:p>
+            <a:r>
+              <a:t>My reminder: do not turn an old calendar entry into a promise. Earlier paper records are incomplete; use current confirmed bookings for 2017 planning.</a:t>
             </a:r>
           </a:p>
         </p:txBody>
@@ -3864,7 +3933,7 @@
                 </a:solidFill>
                 <a:latin typeface="Arial"/>
               </a:rPr>
-              <a:t>Chamber capacity review</a:t>
+              <a:t>Chamber capacity review 2017 — Rev02</a:t>
             </a:r>
           </a:p>
         </p:txBody>
@@ -3896,7 +3965,7 @@
                 </a:solidFill>
                 <a:latin typeface="Times New Roman"/>
               </a:rPr>
-              <a:t>Westravelle Analytical Ltd | Commercial | GB working draft, November 2016</a:t>
+              <a:t>Westravelle Analytical Ltd | Gareth Bramwell | 25 Nov 2016 | Personal meeting copy</a:t>
             </a:r>
           </a:p>
         </p:txBody>
@@ -3979,7 +4048,7 @@
               <a:rPr sz="2000">
                 <a:latin typeface="Times New Roman"/>
               </a:rPr>
-              <a:t>Requests for long-term storage have come in faster than the chamber programme was planned for</a:t>
+              <a:t>Commercial review for the next year: distinguish occupied storage, reservations and space available for new stability lots</a:t>
             </a:r>
           </a:p>
           <a:p>
@@ -3988,7 +4057,7 @@
               <a:rPr sz="2000">
                 <a:latin typeface="Times New Roman"/>
               </a:rPr>
-              <a:t>Several quotes in the autumn were turned down or cut back because we could not confirm a chamber slot</a:t>
+              <a:t>Record occupancy by storage condition and stability lot in the chamber loading record; keep client analytical results out of the commercial summary</a:t>
             </a:r>
           </a:p>
           <a:p>
@@ -3997,7 +4066,7 @@
               <a:rPr sz="2000">
                 <a:latin typeface="Times New Roman"/>
               </a:rPr>
-              <a:t>Need a plain view of what is booked, what is reserved and what is free before the next round of quotes</a:t>
+              <a:t>Check chamber space and analytical capacity before offering a start date</a:t>
             </a:r>
           </a:p>
           <a:p>
@@ -4006,7 +4075,7 @@
               <a:rPr sz="1700">
                 <a:latin typeface="Times New Roman"/>
               </a:rPr>
-              <a:t>Figures here are capacity and scheduling only; no study results are in this deck</a:t>
+              <a:t>This review sets the booking checks; it does not certify current free capacity</a:t>
             </a:r>
           </a:p>
         </p:txBody>
@@ -4134,7 +4203,7 @@
                 </a:solidFill>
                 <a:latin typeface="Arial"/>
               </a:rPr>
-              <a:t>2 Occupancy by chamber</a:t>
+              <a:t>2 Occupancy and reservations — source records</a:t>
             </a:r>
           </a:p>
         </p:txBody>
@@ -4201,10 +4270,9 @@
                 <a:tableStyleId>{5C22544A-7EE6-4342-B048-85BDC9FD1C3A}</a:tableStyleId>
               </a:tblPr>
               <a:tblGrid>
-                <a:gridCol w="2819323"/>
-                <a:gridCol w="2819323"/>
-                <a:gridCol w="2819323"/>
-                <a:gridCol w="2819326"/>
+                <a:gridCol w="3759098"/>
+                <a:gridCol w="3759098"/>
+                <a:gridCol w="3759099"/>
               </a:tblGrid>
               <a:tr h="274320">
                 <a:tc>
@@ -4219,7 +4287,7 @@
                           </a:solidFill>
                           <a:latin typeface="Times New Roman"/>
                         </a:rPr>
-                        <a:t>Chamber</a:t>
+                        <a:t>Record</a:t>
                       </a:r>
                     </a:p>
                   </a:txBody>
@@ -4241,7 +4309,7 @@
                           </a:solidFill>
                           <a:latin typeface="Times New Roman"/>
                         </a:rPr>
-                        <a:t>Programme</a:t>
+                        <a:t>Capacity information to check</a:t>
                       </a:r>
                     </a:p>
                   </a:txBody>
@@ -4263,29 +4331,7 @@
                           </a:solidFill>
                           <a:latin typeface="Times New Roman"/>
                         </a:rPr>
-                        <a:t>Loading status</a:t>
-                      </a:r>
-                    </a:p>
-                  </a:txBody>
-                  <a:tcPr>
-                    <a:solidFill>
-                      <a:srgbClr val="735434"/>
-                    </a:solidFill>
-                  </a:tcPr>
-                </a:tc>
-                <a:tc>
-                  <a:txBody>
-                    <a:bodyPr/>
-                    <a:lstStyle/>
-                    <a:p>
-                      <a:r>
-                        <a:rPr sz="1400" b="1">
-                          <a:solidFill>
-                            <a:srgbClr val="FFFFFF"/>
-                          </a:solidFill>
-                          <a:latin typeface="Times New Roman"/>
-                        </a:rPr>
-                        <a:t>Comment</a:t>
+                        <a:t>Commercial use</a:t>
                       </a:r>
                     </a:p>
                   </a:txBody>
@@ -4306,7 +4352,7 @@
                         <a:rPr sz="1400">
                           <a:latin typeface="Times New Roman"/>
                         </a:rPr>
-                        <a:t>Chamber A</a:t>
+                        <a:t>Chamber loading record</a:t>
                       </a:r>
                     </a:p>
                   </a:txBody>
@@ -4321,7 +4367,7 @@
                         <a:rPr sz="1400">
                           <a:latin typeface="Times New Roman"/>
                         </a:rPr>
-                        <a:t>ICH long-term</a:t>
+                        <a:t>Storage condition, occupied space and stability-lot locations</a:t>
                       </a:r>
                     </a:p>
                   </a:txBody>
@@ -4336,22 +4382,7 @@
                         <a:rPr sz="1400">
                           <a:latin typeface="Times New Roman"/>
                         </a:rPr>
-                        <a:t>Full</a:t>
-                      </a:r>
-                    </a:p>
-                  </a:txBody>
-                  <a:tcPr/>
-                </a:tc>
-                <a:tc>
-                  <a:txBody>
-                    <a:bodyPr/>
-                    <a:lstStyle/>
-                    <a:p>
-                      <a:r>
-                        <a:rPr sz="1400">
-                          <a:latin typeface="Times New Roman"/>
-                        </a:rPr>
-                        <a:t>Stability lots from two projects; no room for new lots until the 12 month pulls</a:t>
+                        <a:t>Identify usable space for the proposed storage condition</a:t>
                       </a:r>
                     </a:p>
                   </a:txBody>
@@ -4368,7 +4399,7 @@
                         <a:rPr sz="1400">
                           <a:latin typeface="Times New Roman"/>
                         </a:rPr>
-                        <a:t>Chamber B</a:t>
+                        <a:t>Reservation record</a:t>
                       </a:r>
                     </a:p>
                   </a:txBody>
@@ -4383,7 +4414,7 @@
                         <a:rPr sz="1400">
                           <a:latin typeface="Times New Roman"/>
                         </a:rPr>
-                        <a:t>ICH intermediate</a:t>
+                        <a:t>Proposed loading, reservation status and booking authority</a:t>
                       </a:r>
                     </a:p>
                   </a:txBody>
@@ -4398,22 +4429,7 @@
                         <a:rPr sz="1400">
                           <a:latin typeface="Times New Roman"/>
                         </a:rPr>
-                        <a:t>Partly reserved</a:t>
-                      </a:r>
-                    </a:p>
-                  </a:txBody>
-                  <a:tcPr/>
-                </a:tc>
-                <a:tc>
-                  <a:txBody>
-                    <a:bodyPr/>
-                    <a:lstStyle/>
-                    <a:p>
-                      <a:r>
-                        <a:rPr sz="1400">
-                          <a:latin typeface="Times New Roman"/>
-                        </a:rPr>
-                        <a:t>Reserved for a protocol that has not yet started; ask Leon whether it is still on</a:t>
+                        <a:t>Distinguish a reservation from confirmed loading</a:t>
                       </a:r>
                     </a:p>
                   </a:txBody>
@@ -4430,7 +4446,7 @@
                         <a:rPr sz="1400">
                           <a:latin typeface="Times New Roman"/>
                         </a:rPr>
-                        <a:t>Chamber C</a:t>
+                        <a:t>Protocol and pull calendar</a:t>
                       </a:r>
                     </a:p>
                   </a:txBody>
@@ -4445,7 +4461,7 @@
                         <a:rPr sz="1400">
                           <a:latin typeface="Times New Roman"/>
                         </a:rPr>
-                        <a:t>Accelerated</a:t>
+                        <a:t>Reserved pull windows and scheduled sample withdrawals</a:t>
                       </a:r>
                     </a:p>
                   </a:txBody>
@@ -4460,22 +4476,7 @@
                         <a:rPr sz="1400">
                           <a:latin typeface="Times New Roman"/>
                         </a:rPr>
-                        <a:t>Free from January</a:t>
-                      </a:r>
-                    </a:p>
-                  </a:txBody>
-                  <a:tcPr/>
-                </a:tc>
-                <a:tc>
-                  <a:txBody>
-                    <a:bodyPr/>
-                    <a:lstStyle/>
-                    <a:p>
-                      <a:r>
-                        <a:rPr sz="1400">
-                          <a:latin typeface="Times New Roman"/>
-                        </a:rPr>
-                        <a:t>Current lots pull out at the end of December</a:t>
+                        <a:t>Check the loading plan against scheduled work</a:t>
                       </a:r>
                     </a:p>
                   </a:txBody>
@@ -4492,7 +4493,7 @@
                         <a:rPr sz="1400">
                           <a:latin typeface="Times New Roman"/>
                         </a:rPr>
-                        <a:t>Chamber D</a:t>
+                        <a:t>Sample retention and disposal record</a:t>
                       </a:r>
                     </a:p>
                   </a:txBody>
@@ -4507,7 +4508,7 @@
                         <a:rPr sz="1400">
                           <a:latin typeface="Times New Roman"/>
                         </a:rPr>
-                        <a:t>Photostability and cycling</a:t>
+                        <a:t>Material that must remain after a pull</a:t>
                       </a:r>
                     </a:p>
                   </a:txBody>
@@ -4522,22 +4523,7 @@
                         <a:rPr sz="1400">
                           <a:latin typeface="Times New Roman"/>
                         </a:rPr>
-                        <a:t>Shared</a:t>
-                      </a:r>
-                    </a:p>
-                  </a:txBody>
-                  <a:tcPr/>
-                </a:tc>
-                <a:tc>
-                  <a:txBody>
-                    <a:bodyPr/>
-                    <a:lstStyle/>
-                    <a:p>
-                      <a:r>
-                        <a:rPr sz="1400">
-                          <a:latin typeface="Times New Roman"/>
-                        </a:rPr>
-                        <a:t>Booked by the method validation group in the same weeks as the cycling work</a:t>
+                        <a:t>Do not assume a pull frees storage space</a:t>
                       </a:r>
                     </a:p>
                   </a:txBody>
@@ -4660,7 +4646,7 @@
               <a:rPr sz="1800">
                 <a:latin typeface="Times New Roman"/>
               </a:rPr>
-              <a:t>Pull points follow the protocol: they are not moved to suit a chamber</a:t>
+              <a:t>Pull points and permitted windows follow the signed protocol</a:t>
             </a:r>
           </a:p>
           <a:p>
@@ -4669,7 +4655,7 @@
               <a:rPr sz="1800">
                 <a:latin typeface="Times New Roman"/>
               </a:rPr>
-              <a:t>Pulls in the same week share a sample trip where possible</a:t>
+              <a:t>Coordinate sample handling within those windows without changing the required storage exposure</a:t>
             </a:r>
           </a:p>
           <a:p>
@@ -4678,7 +4664,7 @@
               <a:rPr sz="1800">
                 <a:latin typeface="Times New Roman"/>
               </a:rPr>
-              <a:t>Late pulls are noted on the batch card with the reason</a:t>
+              <a:t>Late or missed pulls require a deviation note and an assessment of their effect</a:t>
             </a:r>
           </a:p>
         </p:txBody>
@@ -4710,7 +4696,7 @@
               <a:rPr sz="1800">
                 <a:latin typeface="Times New Roman"/>
               </a:rPr>
-              <a:t>Chamber A pulls cluster at the year end, so new loading there is a poor idea before February</a:t>
+              <a:t>Review clustered pulls against analyst and method availability</a:t>
             </a:r>
           </a:p>
           <a:p>
@@ -4719,7 +4705,7 @@
               <a:rPr sz="1800">
                 <a:latin typeface="Times New Roman"/>
               </a:rPr>
-              <a:t>Chamber C has the most flexibility at present</a:t>
+              <a:t>Treat storage space and pull-testing capacity as separate booking constraints</a:t>
             </a:r>
           </a:p>
           <a:p>
@@ -4728,7 +4714,7 @@
               <a:rPr sz="1800">
                 <a:latin typeface="Times New Roman"/>
               </a:rPr>
-              <a:t>Ask the stability coordinator before offering any start date that falls inside a pull window</a:t>
+              <a:t>Confirm reservations with Leon before offering a loading date</a:t>
             </a:r>
           </a:p>
         </p:txBody>
@@ -4888,7 +4874,7 @@
               <a:rPr sz="2000">
                 <a:latin typeface="Times New Roman"/>
               </a:rPr>
-              <a:t>Quotes assume the standard lead time from the rate card, counted from signed protocol to first loading</a:t>
+              <a:t>Quote timing starts from the agreed prerequisites: signed protocol, sample receipt and confirmed storage allocation</a:t>
             </a:r>
           </a:p>
           <a:p>
@@ -4897,7 +4883,7 @@
               <a:rPr sz="2000">
                 <a:latin typeface="Times New Roman"/>
               </a:rPr>
-              <a:t>Where a chamber is full, the quote assumes the next free slot and says so</a:t>
+              <a:t>State dependencies on chamber availability and analytical capacity in the quote</a:t>
             </a:r>
           </a:p>
           <a:p>
@@ -4906,7 +4892,7 @@
               <a:rPr sz="2000">
                 <a:latin typeface="Times New Roman"/>
               </a:rPr>
-              <a:t>Expedited starts are not offered for long-term storage</a:t>
+              <a:t>Treat any proposed expedited start as a separate capacity check before making a commitment</a:t>
             </a:r>
           </a:p>
           <a:p>
@@ -4915,7 +4901,7 @@
               <a:rPr sz="1700">
                 <a:latin typeface="Times New Roman"/>
               </a:rPr>
-              <a:t>Do not promise a start date until the chamber log has been checked</a:t>
+              <a:t>Confirm a start date from current booking records; this review supplies no standard lead-time figure</a:t>
             </a:r>
           </a:p>
           <a:p>
@@ -4924,7 +4910,7 @@
               <a:rPr sz="2000">
                 <a:latin typeface="Times New Roman"/>
               </a:rPr>
-              <a:t>Analytical capacity for the first pull is checked with the QC method validation lead, not assumed</a:t>
+              <a:t>Saira to confirm method readiness and analytical availability for the planned pulls</a:t>
             </a:r>
           </a:p>
         </p:txBody>
@@ -5052,7 +5038,7 @@
                 </a:solidFill>
                 <a:latin typeface="Arial"/>
               </a:rPr>
-              <a:t>5 Open points</a:t>
+              <a:t>5 Quote review actions</a:t>
             </a:r>
           </a:p>
         </p:txBody>
@@ -5084,7 +5070,7 @@
               <a:rPr sz="2000">
                 <a:latin typeface="Times New Roman"/>
               </a:rPr>
-              <a:t>Is the Chamber B reservation still live</a:t>
+              <a:t>Leon: confirm current occupancy, reservation status and the proposed pull windows from the source records</a:t>
             </a:r>
           </a:p>
           <a:p>
@@ -5093,7 +5079,7 @@
               <a:rPr sz="2000">
                 <a:latin typeface="Times New Roman"/>
               </a:rPr>
-              <a:t>Whether the rate card lead time still matches what the labs can actually do</a:t>
+              <a:t>Saira: confirm analytical capacity and method readiness for those windows</a:t>
             </a:r>
           </a:p>
           <a:p>
@@ -5102,7 +5088,7 @@
               <a:rPr sz="2000">
                 <a:latin typeface="Times New Roman"/>
               </a:rPr>
-              <a:t>Who signs off a deviation from the standard lead time: Alice or the QA side</a:t>
+              <a:t>Gareth: state the confirmed timing dependencies in the quotation</a:t>
             </a:r>
           </a:p>
           <a:p>
@@ -5111,7 +5097,7 @@
               <a:rPr sz="2000">
                 <a:latin typeface="Times New Roman"/>
               </a:rPr>
-              <a:t>Whether the old chamber log entries from before 2011 are worth keeping in the summary at all</a:t>
+              <a:t>Alice: resolve capacity exceptions before a commercial commitment</a:t>
             </a:r>
           </a:p>
         </p:txBody>
@@ -5189,193 +5175,6 @@
                 <a:latin typeface="Times New Roman"/>
               </a:rPr>
               <a:t>Westravelle Analytical Ltd | Confidential    6</a:t>
-            </a:r>
-          </a:p>
-        </p:txBody>
-      </p:sp>
-    </p:spTree>
-  </p:cSld>
-  <p:clrMapOvr>
-    <a:masterClrMapping/>
-  </p:clrMapOvr>
-</p:sld>
-</file>
-
-<file path=ppt/slides/slide7.xml><?xml version="1.0" encoding="utf-8"?>
-<p:sld xmlns:a="http://schemas.openxmlformats.org/drawingml/2006/main" xmlns:p="http://schemas.openxmlformats.org/presentationml/2006/main" xmlns:r="http://schemas.openxmlformats.org/officeDocument/2006/relationships">
-  <p:cSld>
-    <p:spTree>
-      <p:nvGrpSpPr>
-        <p:cNvPr id="1" name=""/>
-        <p:cNvGrpSpPr/>
-        <p:nvPr/>
-      </p:nvGrpSpPr>
-      <p:grpSpPr/>
-      <p:sp>
-        <p:nvSpPr>
-          <p:cNvPr id="2" name="Title 1"/>
-          <p:cNvSpPr>
-            <a:spLocks noGrp="1"/>
-          </p:cNvSpPr>
-          <p:nvPr>
-            <p:ph type="title"/>
-          </p:nvPr>
-        </p:nvSpPr>
-        <p:spPr>
-          <a:xfrm>
-            <a:off x="411480" y="137160"/>
-            <a:ext cx="11368735" cy="822960"/>
-          </a:xfrm>
-        </p:spPr>
-        <p:txBody>
-          <a:bodyPr/>
-          <a:lstStyle/>
-          <a:p>
-            <a:pPr algn="l"/>
-            <a:r>
-              <a:rPr sz="2600" b="1">
-                <a:solidFill>
-                  <a:srgbClr val="735434"/>
-                </a:solidFill>
-                <a:latin typeface="Arial"/>
-              </a:rPr>
-              <a:t>6 Next steps</a:t>
-            </a:r>
-          </a:p>
-        </p:txBody>
-      </p:sp>
-      <p:sp>
-        <p:nvSpPr>
-          <p:cNvPr id="3" name="Content Placeholder 2"/>
-          <p:cNvSpPr>
-            <a:spLocks noGrp="1"/>
-          </p:cNvSpPr>
-          <p:nvPr>
-            <p:ph idx="1"/>
-          </p:nvPr>
-        </p:nvSpPr>
-        <p:spPr>
-          <a:xfrm>
-            <a:off x="457200" y="1280160"/>
-            <a:ext cx="11277295" cy="4937760"/>
-          </a:xfrm>
-        </p:spPr>
-        <p:txBody>
-          <a:bodyPr wrap="square">
-            <a:noAutofit/>
-          </a:bodyPr>
-          <a:lstStyle/>
-          <a:p>
-            <a:pPr/>
-            <a:r>
-              <a:rPr sz="2000">
-                <a:latin typeface="Times New Roman"/>
-              </a:rPr>
-              <a:t>Leon to confirm the Chamber B reservation and the Chamber C start</a:t>
-            </a:r>
-          </a:p>
-          <a:p>
-            <a:pPr/>
-            <a:r>
-              <a:rPr sz="2000">
-                <a:latin typeface="Times New Roman"/>
-              </a:rPr>
-              <a:t>Saira to confirm analytical slots for the pulls that fall in January</a:t>
-            </a:r>
-          </a:p>
-          <a:p>
-            <a:pPr/>
-            <a:r>
-              <a:rPr sz="2000">
-                <a:latin typeface="Times New Roman"/>
-              </a:rPr>
-              <a:t>Gareth to redraft the lead-time paragraph for the rate card</a:t>
-            </a:r>
-          </a:p>
-          <a:p>
-            <a:pPr lvl="1"/>
-            <a:r>
-              <a:rPr sz="1700">
-                <a:latin typeface="Times New Roman"/>
-              </a:rPr>
-              <a:t>Circulate to Alice before the next quote review</a:t>
-            </a:r>
-          </a:p>
-        </p:txBody>
-      </p:sp>
-      <p:sp>
-        <p:nvSpPr>
-          <p:cNvPr id="4" name="Rectangle 3"/>
-          <p:cNvSpPr/>
-          <p:nvPr/>
-        </p:nvSpPr>
-        <p:spPr>
-          <a:xfrm>
-            <a:off x="0" y="0"/>
-            <a:ext cx="201168" cy="6858000"/>
-          </a:xfrm>
-          <a:prstGeom prst="rect">
-            <a:avLst/>
-          </a:prstGeom>
-          <a:solidFill>
-            <a:srgbClr val="735434"/>
-          </a:solidFill>
-          <a:ln>
-            <a:noFill/>
-          </a:ln>
-        </p:spPr>
-        <p:style>
-          <a:lnRef idx="1">
-            <a:schemeClr val="accent1"/>
-          </a:lnRef>
-          <a:fillRef idx="3">
-            <a:schemeClr val="accent1"/>
-          </a:fillRef>
-          <a:effectRef idx="2">
-            <a:schemeClr val="accent1"/>
-          </a:effectRef>
-          <a:fontRef idx="minor">
-            <a:schemeClr val="lt1"/>
-          </a:fontRef>
-        </p:style>
-        <p:txBody>
-          <a:bodyPr rtlCol="0" anchor="ctr"/>
-          <a:lstStyle/>
-          <a:p>
-            <a:pPr algn="ctr"/>
-          </a:p>
-        </p:txBody>
-      </p:sp>
-      <p:sp>
-        <p:nvSpPr>
-          <p:cNvPr id="5" name="TextBox 4"/>
-          <p:cNvSpPr txBox="1"/>
-          <p:nvPr/>
-        </p:nvSpPr>
-        <p:spPr>
-          <a:xfrm>
-            <a:off x="365760" y="6446520"/>
-            <a:ext cx="11460175" cy="274320"/>
-          </a:xfrm>
-          <a:prstGeom prst="rect">
-            <a:avLst/>
-          </a:prstGeom>
-          <a:noFill/>
-        </p:spPr>
-        <p:txBody>
-          <a:bodyPr wrap="none">
-            <a:spAutoFit/>
-          </a:bodyPr>
-          <a:lstStyle/>
-          <a:p>
-            <a:r>
-              <a:rPr sz="800">
-                <a:solidFill>
-                  <a:srgbClr val="6E6E6E"/>
-                </a:solidFill>
-                <a:latin typeface="Times New Roman"/>
-              </a:rPr>
-              <a:t>Westravelle Analytical Ltd | Confidential    7</a:t>
             </a:r>
           </a:p>
         </p:txBody>

</xml_diff>